<commit_message>
docs: switch beforeHook transform examples to JSONata syntax
Replace the pseudo-code list/dict transform with JSONata expressions in
the mechanism doc, example page, and example PPT; add landing constraints
(policy-authored only, fail-closed, no $eval, singleton normalization,
version pinning) and the take-first-18 variant.

Co-authored-by: Lizzy67 <Lizzy67@users.noreply.github.com>
</commit_message>
<xml_diff>
--- a/docs/tool_param_ref_example.pptx
+++ b/docs/tool_param_ref_example.pptx
@@ -6153,7 +6153,7 @@
                 </a:solidFill>
                 <a:latin typeface="Microsoft YaHei"/>
               </a:rPr>
-              <a:t>BeforeHook Policy：入参结构转换</a:t>
+              <a:t>BeforeHook Policy：入参结构转换（JSONata）</a:t>
             </a:r>
           </a:p>
         </p:txBody>
@@ -6300,7 +6300,7 @@
                 </a:solidFill>
                 <a:latin typeface="Consolas"/>
               </a:rPr>
-              <a:t>  images: list(dict("file_id", string(item)) for item in </a:t>
+              <a:t>  images: "$map(</a:t>
             </a:r>
             <a:r>
               <a:rPr sz="750" b="1">
@@ -6309,7 +6309,7 @@
                 </a:solidFill>
                 <a:latin typeface="Consolas"/>
               </a:rPr>
-              <a:t>$value</a:t>
+              <a:t>$</a:t>
             </a:r>
             <a:r>
               <a:rPr sz="750" b="0">
@@ -6318,7 +6318,7 @@
                 </a:solidFill>
                 <a:latin typeface="Consolas"/>
               </a:rPr>
-              <a:t>)</a:t>
+              <a:t>, function($v) {{ 'file_id': $string($v) }})"</a:t>
             </a:r>
           </a:p>
           <a:p>
@@ -6356,7 +6356,7 @@
                 </a:solidFill>
                 <a:latin typeface="Consolas"/>
               </a:rPr>
-              <a:t># $value = 引用展开后的真实列表；publishNote 无需转换，仅求值与 Schema 校验</a:t>
+              <a:t># $ = 引用展开后的真实列表；限量取前 18：$map($[[0..17]], …)；求值失败即短路</a:t>
             </a:r>
           </a:p>
         </p:txBody>

</xml_diff>

<commit_message>
docs: keep pseudo-code alongside JSONata for comparison
Co-authored-by: Lizzy67 <Lizzy67@users.noreply.github.com>
</commit_message>
<xml_diff>
--- a/docs/tool_param_ref_example.pptx
+++ b/docs/tool_param_ref_example.pptx
@@ -6153,7 +6153,7 @@
                 </a:solidFill>
                 <a:latin typeface="Microsoft YaHei"/>
               </a:rPr>
-              <a:t>BeforeHook Policy：入参结构转换（JSONata）</a:t>
+              <a:t>BeforeHook Policy：入参结构转换（伪代码 vs JSONata）</a:t>
             </a:r>
           </a:p>
         </p:txBody>
@@ -6277,11 +6277,29 @@
             <a:r>
               <a:rPr sz="750" b="0">
                 <a:solidFill>
-                  <a:srgbClr val="1C2925"/>
+                  <a:srgbClr val="9AA8A2"/>
                 </a:solidFill>
                 <a:latin typeface="Consolas"/>
               </a:rPr>
-              <a:t>createCollage.beforeHookPolicy {</a:t>
+              <a:t># 伪代码  images: list(dict("file_id", string(item)) for item in </a:t>
+            </a:r>
+            <a:r>
+              <a:rPr sz="750" b="1">
+                <a:solidFill>
+                  <a:srgbClr val="0B544E"/>
+                </a:solidFill>
+                <a:latin typeface="Consolas"/>
+              </a:rPr>
+              <a:t>$value</a:t>
+            </a:r>
+            <a:r>
+              <a:rPr sz="750" b="0">
+                <a:solidFill>
+                  <a:srgbClr val="9AA8A2"/>
+                </a:solidFill>
+                <a:latin typeface="Consolas"/>
+              </a:rPr>
+              <a:t>)</a:t>
             </a:r>
           </a:p>
           <a:p>
@@ -6300,25 +6318,7 @@
                 </a:solidFill>
                 <a:latin typeface="Consolas"/>
               </a:rPr>
-              <a:t>  images: "$map(</a:t>
-            </a:r>
-            <a:r>
-              <a:rPr sz="750" b="1">
-                <a:solidFill>
-                  <a:srgbClr val="0B544E"/>
-                </a:solidFill>
-                <a:latin typeface="Consolas"/>
-              </a:rPr>
-              <a:t>$</a:t>
-            </a:r>
-            <a:r>
-              <a:rPr sz="750" b="0">
-                <a:solidFill>
-                  <a:srgbClr val="1C2925"/>
-                </a:solidFill>
-                <a:latin typeface="Consolas"/>
-              </a:rPr>
-              <a:t>, function($v) {{ 'file_id': $string($v) }})"</a:t>
+              <a:t>createCollage.beforeHookPolicy {</a:t>
             </a:r>
           </a:p>
           <a:p>
@@ -6337,7 +6337,25 @@
                 </a:solidFill>
                 <a:latin typeface="Consolas"/>
               </a:rPr>
-              <a:t>}</a:t>
+              <a:t>  images: "$map(</a:t>
+            </a:r>
+            <a:r>
+              <a:rPr sz="750" b="1">
+                <a:solidFill>
+                  <a:srgbClr val="0B544E"/>
+                </a:solidFill>
+                <a:latin typeface="Consolas"/>
+              </a:rPr>
+              <a:t>$</a:t>
+            </a:r>
+            <a:r>
+              <a:rPr sz="750" b="0">
+                <a:solidFill>
+                  <a:srgbClr val="1C2925"/>
+                </a:solidFill>
+                <a:latin typeface="Consolas"/>
+              </a:rPr>
+              <a:t>, function($v) {{ 'file_id': $string($v) }})"   # JSONata 等价</a:t>
             </a:r>
           </a:p>
           <a:p>
@@ -6356,7 +6374,7 @@
                 </a:solidFill>
                 <a:latin typeface="Consolas"/>
               </a:rPr>
-              <a:t># $ = 引用展开后的真实列表；限量取前 18：$map($[[0..17]], …)；求值失败即短路</a:t>
+              <a:t>}  # 限量取前 18：$map($[[0..17]], …)；求值失败即短路</a:t>
             </a:r>
           </a:p>
         </p:txBody>

</xml_diff>